<commit_message>
Baton: in-tool demo reset, and merge slide content to one slide (concept on top)
- pages/2_Baton.py, baton/kt_store.py: Manager sidebar "Demo controls" ->
  confirm-gated "Reset to the 5 demo KTs" button. reset_to_seed() wipes
  data/kt/ and restores the bundled baton/seed_kt/ set (the same 5 KTs
  covering every decision-rule branch), no API calls, instant. Replaces
  running the seed script outside the tool.
- slide_src/generate_baton_slide.py: consolidated the overview + workflow
  slides into a single slide (6-step workflow strip + AI/code role split
  folded into the 3-column problem/how-AI/value layout), then swapped the
  order so concept sits on top and the workflow strip sits below it.
- Baton_One_Pager.pptx, BPM_2026_Day1_PitchDemo_VibeTribe.pptx: regenerated
  from the above (submission deck is now 2 slides: Relook + Baton).

Co-Authored-By: Claude Sonnet 5 <noreply@anthropic.com>
</commit_message>
<xml_diff>
--- a/BPM_2026_Day1_PitchDemo_VibeTribe.pptx
+++ b/BPM_2026_Day1_PitchDemo_VibeTribe.pptx
@@ -7,7 +7,6 @@
   <p:sldIdLst>
     <p:sldId id="256" r:id="rId7"/>
     <p:sldId id="257" r:id="rId9"/>
-    <p:sldId id="258" r:id="rId10"/>
   </p:sldIdLst>
   <p:sldSz cx="12191695" cy="6858000" type="screen4x3"/>
   <p:notesSz cx="6858000" cy="9144000"/>
@@ -5838,7 +5837,7 @@
         <p:spPr>
           <a:xfrm>
             <a:off x="0" y="0"/>
-            <a:ext cx="12191695" cy="1234440"/>
+            <a:ext cx="12191695" cy="868680"/>
           </a:xfrm>
           <a:prstGeom prst="rect">
             <a:avLst/>
@@ -5881,8 +5880,8 @@
         </p:nvSpPr>
         <p:spPr>
           <a:xfrm>
-            <a:off x="457200" y="182880"/>
-            <a:ext cx="7863840" cy="566928"/>
+            <a:off x="457200" y="118872"/>
+            <a:ext cx="7863840" cy="457200"/>
           </a:xfrm>
           <a:prstGeom prst="rect">
             <a:avLst/>
@@ -5901,7 +5900,7 @@
               </a:lnSpc>
             </a:pPr>
             <a:r>
-              <a:rPr sz="3400" b="1" i="0">
+              <a:rPr sz="2800" b="1" i="0">
                 <a:solidFill>
                   <a:srgbClr val="FFFFFF"/>
                 </a:solidFill>
@@ -5920,8 +5919,8 @@
         </p:nvSpPr>
         <p:spPr>
           <a:xfrm>
-            <a:off x="457200" y="749808"/>
-            <a:ext cx="7863840" cy="384048"/>
+            <a:off x="457200" y="566928"/>
+            <a:ext cx="7863840" cy="274320"/>
           </a:xfrm>
           <a:prstGeom prst="rect">
             <a:avLst/>
@@ -5940,7 +5939,7 @@
               </a:lnSpc>
             </a:pPr>
             <a:r>
-              <a:rPr sz="1500" b="0" i="1">
+              <a:rPr sz="1300" b="0" i="1">
                 <a:solidFill>
                   <a:srgbClr val="CADCFC"/>
                 </a:solidFill>
@@ -5959,8 +5958,8 @@
         </p:nvSpPr>
         <p:spPr>
           <a:xfrm>
-            <a:off x="9281160" y="329184"/>
-            <a:ext cx="2450592" cy="566928"/>
+            <a:off x="9464040" y="182880"/>
+            <a:ext cx="2267712" cy="512064"/>
           </a:xfrm>
           <a:prstGeom prst="roundRect">
             <a:avLst>
@@ -5995,7 +5994,7 @@
           <a:p>
             <a:pPr algn="ctr"/>
             <a:r>
-              <a:rPr sz="1100" b="1">
+              <a:rPr sz="1000" b="1">
                 <a:solidFill>
                   <a:srgbClr val="1B2340"/>
                 </a:solidFill>
@@ -6011,7 +6010,7 @@
               </a:spcBef>
             </a:pPr>
             <a:r>
-              <a:rPr sz="900" b="1">
+              <a:rPr sz="800" b="1">
                 <a:solidFill>
                   <a:srgbClr val="1B2340"/>
                 </a:solidFill>
@@ -6030,8 +6029,8 @@
         </p:nvSpPr>
         <p:spPr>
           <a:xfrm>
-            <a:off x="457200" y="1508760"/>
-            <a:ext cx="3566160" cy="4434840"/>
+            <a:off x="457200" y="1005840"/>
+            <a:ext cx="3566160" cy="3703320"/>
           </a:xfrm>
           <a:prstGeom prst="roundRect">
             <a:avLst>
@@ -6076,8 +6075,8 @@
         </p:nvSpPr>
         <p:spPr>
           <a:xfrm>
-            <a:off x="731520" y="1783080"/>
-            <a:ext cx="548640" cy="548640"/>
+            <a:off x="694944" y="1243584"/>
+            <a:ext cx="475488" cy="475488"/>
           </a:xfrm>
           <a:prstGeom prst="ellipse">
             <a:avLst/>
@@ -6110,7 +6109,7 @@
           <a:p>
             <a:pPr algn="ctr"/>
             <a:r>
-              <a:rPr sz="2200" b="1">
+              <a:rPr sz="1900" b="1">
                 <a:solidFill>
                   <a:srgbClr val="FFFFFF"/>
                 </a:solidFill>
@@ -6129,8 +6128,8 @@
         </p:nvSpPr>
         <p:spPr>
           <a:xfrm>
-            <a:off x="1417320" y="1783080"/>
-            <a:ext cx="2331720" cy="548640"/>
+            <a:off x="1298448" y="1243584"/>
+            <a:ext cx="2468880" cy="475488"/>
           </a:xfrm>
           <a:prstGeom prst="rect">
             <a:avLst/>
@@ -6149,7 +6148,7 @@
               </a:lnSpc>
             </a:pPr>
             <a:r>
-              <a:rPr sz="1900" b="1" i="0">
+              <a:rPr sz="1650" b="1" i="0">
                 <a:solidFill>
                   <a:srgbClr val="1B2340"/>
                 </a:solidFill>
@@ -6168,8 +6167,8 @@
         </p:nvSpPr>
         <p:spPr>
           <a:xfrm>
-            <a:off x="4297680" y="1508760"/>
-            <a:ext cx="3566160" cy="4434840"/>
+            <a:off x="4297680" y="1005840"/>
+            <a:ext cx="3566160" cy="3703320"/>
           </a:xfrm>
           <a:prstGeom prst="roundRect">
             <a:avLst>
@@ -6214,8 +6213,8 @@
         </p:nvSpPr>
         <p:spPr>
           <a:xfrm>
-            <a:off x="4572000" y="1783080"/>
-            <a:ext cx="548640" cy="548640"/>
+            <a:off x="4535424" y="1243584"/>
+            <a:ext cx="475488" cy="475488"/>
           </a:xfrm>
           <a:prstGeom prst="ellipse">
             <a:avLst/>
@@ -6248,7 +6247,7 @@
           <a:p>
             <a:pPr algn="ctr"/>
             <a:r>
-              <a:rPr sz="2200" b="1">
+              <a:rPr sz="1900" b="1">
                 <a:solidFill>
                   <a:srgbClr val="FFFFFF"/>
                 </a:solidFill>
@@ -6267,8 +6266,8 @@
         </p:nvSpPr>
         <p:spPr>
           <a:xfrm>
-            <a:off x="5257800" y="1783080"/>
-            <a:ext cx="2331720" cy="548640"/>
+            <a:off x="5138928" y="1243584"/>
+            <a:ext cx="2468880" cy="475488"/>
           </a:xfrm>
           <a:prstGeom prst="rect">
             <a:avLst/>
@@ -6287,7 +6286,7 @@
               </a:lnSpc>
             </a:pPr>
             <a:r>
-              <a:rPr sz="1900" b="1" i="0">
+              <a:rPr sz="1650" b="1" i="0">
                 <a:solidFill>
                   <a:srgbClr val="1B2340"/>
                 </a:solidFill>
@@ -6306,8 +6305,8 @@
         </p:nvSpPr>
         <p:spPr>
           <a:xfrm>
-            <a:off x="8138160" y="1508760"/>
-            <a:ext cx="3566160" cy="4434840"/>
+            <a:off x="8138160" y="1005840"/>
+            <a:ext cx="3566160" cy="3703320"/>
           </a:xfrm>
           <a:prstGeom prst="roundRect">
             <a:avLst>
@@ -6352,8 +6351,8 @@
         </p:nvSpPr>
         <p:spPr>
           <a:xfrm>
-            <a:off x="8412480" y="1783080"/>
-            <a:ext cx="548640" cy="548640"/>
+            <a:off x="8375904" y="1243584"/>
+            <a:ext cx="475488" cy="475488"/>
           </a:xfrm>
           <a:prstGeom prst="ellipse">
             <a:avLst/>
@@ -6386,7 +6385,7 @@
           <a:p>
             <a:pPr algn="ctr"/>
             <a:r>
-              <a:rPr sz="2200" b="1">
+              <a:rPr sz="1900" b="1">
                 <a:solidFill>
                   <a:srgbClr val="FFFFFF"/>
                 </a:solidFill>
@@ -6405,8 +6404,8 @@
         </p:nvSpPr>
         <p:spPr>
           <a:xfrm>
-            <a:off x="9098280" y="1783080"/>
-            <a:ext cx="2331720" cy="548640"/>
+            <a:off x="8979408" y="1243584"/>
+            <a:ext cx="2468880" cy="475488"/>
           </a:xfrm>
           <a:prstGeom prst="rect">
             <a:avLst/>
@@ -6425,7 +6424,7 @@
               </a:lnSpc>
             </a:pPr>
             <a:r>
-              <a:rPr sz="1900" b="1" i="0">
+              <a:rPr sz="1650" b="1" i="0">
                 <a:solidFill>
                   <a:srgbClr val="1B2340"/>
                 </a:solidFill>
@@ -6444,8 +6443,8 @@
         </p:nvSpPr>
         <p:spPr>
           <a:xfrm>
-            <a:off x="731520" y="2560320"/>
-            <a:ext cx="3017520" cy="3108959"/>
+            <a:off x="713232" y="1901952"/>
+            <a:ext cx="3054096" cy="2606039"/>
           </a:xfrm>
           <a:prstGeom prst="rect">
             <a:avLst/>
@@ -6460,14 +6459,14 @@
           <a:p>
             <a:pPr algn="l">
               <a:lnSpc>
-                <a:spcPct val="108000"/>
+                <a:spcPct val="104000"/>
               </a:lnSpc>
               <a:spcAft>
-                <a:spcPts val="600"/>
+                <a:spcPts val="500"/>
               </a:spcAft>
             </a:pPr>
             <a:r>
-              <a:rPr sz="1200" b="1">
+              <a:rPr sz="1100" b="1">
                 <a:solidFill>
                   <a:srgbClr val="F2A93B"/>
                 </a:solidFill>
@@ -6476,26 +6475,26 @@
               <a:t>●  </a:t>
             </a:r>
             <a:r>
-              <a:rPr sz="1400">
+              <a:rPr sz="1300">
                 <a:solidFill>
                   <a:srgbClr val="1B2340"/>
                 </a:solidFill>
                 <a:latin typeface="Calibri"/>
               </a:rPr>
-              <a:t>KT is a meeting and a checklist: the giver believes they explained, the taker believes they understood</a:t>
+              <a:t>KT is a meeting and a checklist: nobody tests whether the giver and taker actually agree</a:t>
             </a:r>
           </a:p>
           <a:p>
             <a:pPr algn="l">
               <a:lnSpc>
-                <a:spcPct val="108000"/>
+                <a:spcPct val="104000"/>
               </a:lnSpc>
               <a:spcAft>
-                <a:spcPts val="600"/>
+                <a:spcPts val="500"/>
               </a:spcAft>
             </a:pPr>
             <a:r>
-              <a:rPr sz="1200" b="1">
+              <a:rPr sz="1100" b="1">
                 <a:solidFill>
                   <a:srgbClr val="F2A93B"/>
                 </a:solidFill>
@@ -6504,26 +6503,26 @@
               <a:t>●  </a:t>
             </a:r>
             <a:r>
-              <a:rPr sz="1400">
+              <a:rPr sz="1300">
                 <a:solidFill>
                   <a:srgbClr val="1B2340"/>
                 </a:solidFill>
                 <a:latin typeface="Calibri"/>
               </a:rPr>
-              <a:t>Nobody tests whether the two accounts match</a:t>
+              <a:t>Gaps surface months later as incidents and slow ramp-up</a:t>
             </a:r>
           </a:p>
           <a:p>
             <a:pPr algn="l">
               <a:lnSpc>
-                <a:spcPct val="108000"/>
+                <a:spcPct val="104000"/>
               </a:lnSpc>
               <a:spcAft>
-                <a:spcPts val="600"/>
+                <a:spcPts val="500"/>
               </a:spcAft>
             </a:pPr>
             <a:r>
-              <a:rPr sz="1200" b="1">
+              <a:rPr sz="1100" b="1">
                 <a:solidFill>
                   <a:srgbClr val="F2A93B"/>
                 </a:solidFill>
@@ -6532,41 +6531,13 @@
               <a:t>●  </a:t>
             </a:r>
             <a:r>
-              <a:rPr sz="1400">
+              <a:rPr sz="1300">
                 <a:solidFill>
                   <a:srgbClr val="1B2340"/>
                 </a:solidFill>
                 <a:latin typeface="Calibri"/>
               </a:rPr>
-              <a:t>Gaps surface months later as incidents and slow ramp-up</a:t>
-            </a:r>
-          </a:p>
-          <a:p>
-            <a:pPr algn="l">
-              <a:lnSpc>
-                <a:spcPct val="108000"/>
-              </a:lnSpc>
-              <a:spcAft>
-                <a:spcPts val="600"/>
-              </a:spcAft>
-            </a:pPr>
-            <a:r>
-              <a:rPr sz="1200" b="1">
-                <a:solidFill>
-                  <a:srgbClr val="F2A93B"/>
-                </a:solidFill>
-                <a:latin typeface="Calibri"/>
-              </a:rPr>
-              <a:t>●  </a:t>
-            </a:r>
-            <a:r>
-              <a:rPr sz="1400">
-                <a:solidFill>
-                  <a:srgbClr val="1B2340"/>
-                </a:solidFill>
-                <a:latin typeface="Calibri"/>
-              </a:rPr>
-              <a:t>Project managers cannot see KT status, blockers or who is holding it up</a:t>
+              <a:t>Project managers can't see KT status, blockers, or who is holding it up</a:t>
             </a:r>
           </a:p>
         </p:txBody>
@@ -6579,8 +6550,8 @@
         </p:nvSpPr>
         <p:spPr>
           <a:xfrm>
-            <a:off x="4572000" y="2560320"/>
-            <a:ext cx="3017520" cy="3108959"/>
+            <a:off x="4553712" y="1901952"/>
+            <a:ext cx="3054096" cy="2606039"/>
           </a:xfrm>
           <a:prstGeom prst="rect">
             <a:avLst/>
@@ -6595,14 +6566,14 @@
           <a:p>
             <a:pPr algn="l">
               <a:lnSpc>
-                <a:spcPct val="108000"/>
+                <a:spcPct val="104000"/>
               </a:lnSpc>
               <a:spcAft>
-                <a:spcPts val="600"/>
+                <a:spcPts val="500"/>
               </a:spcAft>
             </a:pPr>
             <a:r>
-              <a:rPr sz="1150" b="1">
+              <a:rPr sz="1050" b="1">
                 <a:solidFill>
                   <a:srgbClr val="F2A93B"/>
                 </a:solidFill>
@@ -6611,26 +6582,26 @@
               <a:t>●  </a:t>
             </a:r>
             <a:r>
-              <a:rPr sz="1350">
+              <a:rPr sz="1250">
                 <a:solidFill>
                   <a:srgbClr val="1B2340"/>
                 </a:solidFill>
                 <a:latin typeface="Calibri"/>
               </a:rPr>
-              <a:t>PM enters project, roles, stack, dev/test environments and duration</a:t>
+              <a:t>AI asks giver and taker separately; round 2 follows up on weak angles only</a:t>
             </a:r>
           </a:p>
           <a:p>
             <a:pPr algn="l">
               <a:lnSpc>
-                <a:spcPct val="108000"/>
+                <a:spcPct val="104000"/>
               </a:lnSpc>
               <a:spcAft>
-                <a:spcPts val="600"/>
+                <a:spcPts val="500"/>
               </a:spcAft>
             </a:pPr>
             <a:r>
-              <a:rPr sz="1150" b="1">
+              <a:rPr sz="1050" b="1">
                 <a:solidFill>
                   <a:srgbClr val="F2A93B"/>
                 </a:solidFill>
@@ -6639,26 +6610,26 @@
               <a:t>●  </a:t>
             </a:r>
             <a:r>
-              <a:rPr sz="1350">
+              <a:rPr sz="1250">
                 <a:solidFill>
                   <a:srgbClr val="1B2340"/>
                 </a:solidFill>
                 <a:latin typeface="Calibri"/>
               </a:rPr>
-              <a:t>AI writes tailored questions across 12 KT angles, separately for giver and taker</a:t>
+              <a:t>Code verifies quotes and scores readiness against the manager's target</a:t>
             </a:r>
           </a:p>
           <a:p>
             <a:pPr algn="l">
               <a:lnSpc>
-                <a:spcPct val="108000"/>
+                <a:spcPct val="104000"/>
               </a:lnSpc>
               <a:spcAft>
-                <a:spcPts val="600"/>
+                <a:spcPts val="500"/>
               </a:spcAft>
             </a:pPr>
             <a:r>
-              <a:rPr sz="1150" b="1">
+              <a:rPr sz="1050" b="1">
                 <a:solidFill>
                   <a:srgbClr val="F2A93B"/>
                 </a:solidFill>
@@ -6667,26 +6638,26 @@
               <a:t>●  </a:t>
             </a:r>
             <a:r>
-              <a:rPr sz="1350">
+              <a:rPr sz="1250">
                 <a:solidFill>
                   <a:srgbClr val="1B2340"/>
                 </a:solidFill>
                 <a:latin typeface="Calibri"/>
               </a:rPr>
-              <a:t>Answers are recorded independently, then compared for gaps and mismatches</a:t>
+              <a:t>AI recommends and reviews action items; code decides close / redress / escalate</a:t>
             </a:r>
           </a:p>
           <a:p>
             <a:pPr algn="l">
               <a:lnSpc>
-                <a:spcPct val="108000"/>
+                <a:spcPct val="104000"/>
               </a:lnSpc>
               <a:spcAft>
-                <a:spcPts val="600"/>
+                <a:spcPts val="500"/>
               </a:spcAft>
             </a:pPr>
             <a:r>
-              <a:rPr sz="1150" b="1">
+              <a:rPr sz="1050" b="1">
                 <a:solidFill>
                   <a:srgbClr val="F2A93B"/>
                 </a:solidFill>
@@ -6695,41 +6666,13 @@
               <a:t>●  </a:t>
             </a:r>
             <a:r>
-              <a:rPr sz="1350">
+              <a:rPr sz="1250">
                 <a:solidFill>
                   <a:srgbClr val="1B2340"/>
                 </a:solidFill>
                 <a:latin typeface="Calibri"/>
               </a:rPr>
-              <a:t>Gaps become action items for giver or taker; their responses are reviewed</a:t>
-            </a:r>
-          </a:p>
-          <a:p>
-            <a:pPr algn="l">
-              <a:lnSpc>
-                <a:spcPct val="108000"/>
-              </a:lnSpc>
-              <a:spcAft>
-                <a:spcPts val="600"/>
-              </a:spcAft>
-            </a:pPr>
-            <a:r>
-              <a:rPr sz="1150" b="1">
-                <a:solidFill>
-                  <a:srgbClr val="F2A93B"/>
-                </a:solidFill>
-                <a:latin typeface="Calibri"/>
-              </a:rPr>
-              <a:t>●  </a:t>
-            </a:r>
-            <a:r>
-              <a:rPr sz="1350">
-                <a:solidFill>
-                  <a:srgbClr val="1B2340"/>
-                </a:solidFill>
-                <a:latin typeface="Calibri"/>
-              </a:rPr>
-              <a:t>Code decides: close, keep open for redress, or escalate</a:t>
+              <a:t>Full audit trail: every question, answer, action and decision is logged</a:t>
             </a:r>
           </a:p>
         </p:txBody>
@@ -6742,8 +6685,8 @@
         </p:nvSpPr>
         <p:spPr>
           <a:xfrm>
-            <a:off x="8412480" y="2560320"/>
-            <a:ext cx="914400" cy="502920"/>
+            <a:off x="8394192" y="1901952"/>
+            <a:ext cx="944879" cy="420624"/>
           </a:xfrm>
           <a:prstGeom prst="rect">
             <a:avLst/>
@@ -6762,7 +6705,7 @@
               </a:lnSpc>
             </a:pPr>
             <a:r>
-              <a:rPr sz="2600" b="1" i="0">
+              <a:rPr sz="2100" b="1" i="0">
                 <a:solidFill>
                   <a:srgbClr val="F2A93B"/>
                 </a:solidFill>
@@ -6781,8 +6724,8 @@
         </p:nvSpPr>
         <p:spPr>
           <a:xfrm>
-            <a:off x="8412480" y="3063239"/>
-            <a:ext cx="914400" cy="457200"/>
+            <a:off x="8394192" y="2322576"/>
+            <a:ext cx="944879" cy="384048"/>
           </a:xfrm>
           <a:prstGeom prst="rect">
             <a:avLst/>
@@ -6801,7 +6744,7 @@
               </a:lnSpc>
             </a:pPr>
             <a:r>
-              <a:rPr sz="950" b="0" i="0">
+              <a:rPr sz="850" b="0" i="0">
                 <a:solidFill>
                   <a:srgbClr val="555F75"/>
                 </a:solidFill>
@@ -6817,7 +6760,7 @@
               </a:lnSpc>
             </a:pPr>
             <a:r>
-              <a:rPr sz="950" b="0" i="0">
+              <a:rPr sz="850" b="0" i="0">
                 <a:solidFill>
                   <a:srgbClr val="555F75"/>
                 </a:solidFill>
@@ -6836,8 +6779,8 @@
         </p:nvSpPr>
         <p:spPr>
           <a:xfrm>
-            <a:off x="9464040" y="2560320"/>
-            <a:ext cx="914400" cy="502920"/>
+            <a:off x="9448799" y="1901952"/>
+            <a:ext cx="944879" cy="420624"/>
           </a:xfrm>
           <a:prstGeom prst="rect">
             <a:avLst/>
@@ -6856,7 +6799,7 @@
               </a:lnSpc>
             </a:pPr>
             <a:r>
-              <a:rPr sz="2600" b="1" i="0">
+              <a:rPr sz="2100" b="1" i="0">
                 <a:solidFill>
                   <a:srgbClr val="F2A93B"/>
                 </a:solidFill>
@@ -6875,8 +6818,8 @@
         </p:nvSpPr>
         <p:spPr>
           <a:xfrm>
-            <a:off x="9464040" y="3063239"/>
-            <a:ext cx="914400" cy="457200"/>
+            <a:off x="9448799" y="2322576"/>
+            <a:ext cx="944879" cy="384048"/>
           </a:xfrm>
           <a:prstGeom prst="rect">
             <a:avLst/>
@@ -6895,7 +6838,7 @@
               </a:lnSpc>
             </a:pPr>
             <a:r>
-              <a:rPr sz="950" b="0" i="0">
+              <a:rPr sz="850" b="0" i="0">
                 <a:solidFill>
                   <a:srgbClr val="555F75"/>
                 </a:solidFill>
@@ -6911,7 +6854,7 @@
               </a:lnSpc>
             </a:pPr>
             <a:r>
-              <a:rPr sz="950" b="0" i="0">
+              <a:rPr sz="850" b="0" i="0">
                 <a:solidFill>
                   <a:srgbClr val="555F75"/>
                 </a:solidFill>
@@ -6930,8 +6873,8 @@
         </p:nvSpPr>
         <p:spPr>
           <a:xfrm>
-            <a:off x="10515600" y="2560320"/>
-            <a:ext cx="914400" cy="502920"/>
+            <a:off x="10503408" y="1901952"/>
+            <a:ext cx="944879" cy="420624"/>
           </a:xfrm>
           <a:prstGeom prst="rect">
             <a:avLst/>
@@ -6950,7 +6893,7 @@
               </a:lnSpc>
             </a:pPr>
             <a:r>
-              <a:rPr sz="2600" b="1" i="0">
+              <a:rPr sz="2100" b="1" i="0">
                 <a:solidFill>
                   <a:srgbClr val="F2A93B"/>
                 </a:solidFill>
@@ -6969,8 +6912,8 @@
         </p:nvSpPr>
         <p:spPr>
           <a:xfrm>
-            <a:off x="10515600" y="3063239"/>
-            <a:ext cx="914400" cy="457200"/>
+            <a:off x="10503408" y="2322576"/>
+            <a:ext cx="944879" cy="384048"/>
           </a:xfrm>
           <a:prstGeom prst="rect">
             <a:avLst/>
@@ -6989,7 +6932,7 @@
               </a:lnSpc>
             </a:pPr>
             <a:r>
-              <a:rPr sz="950" b="0" i="0">
+              <a:rPr sz="850" b="0" i="0">
                 <a:solidFill>
                   <a:srgbClr val="555F75"/>
                 </a:solidFill>
@@ -7005,7 +6948,7 @@
               </a:lnSpc>
             </a:pPr>
             <a:r>
-              <a:rPr sz="950" b="0" i="0">
+              <a:rPr sz="850" b="0" i="0">
                 <a:solidFill>
                   <a:srgbClr val="555F75"/>
                 </a:solidFill>
@@ -7024,8 +6967,8 @@
         </p:nvSpPr>
         <p:spPr>
           <a:xfrm>
-            <a:off x="8412480" y="3703320"/>
-            <a:ext cx="3017520" cy="1965960"/>
+            <a:off x="8394192" y="2834640"/>
+            <a:ext cx="3054096" cy="1737360"/>
           </a:xfrm>
           <a:prstGeom prst="rect">
             <a:avLst/>
@@ -7040,14 +6983,14 @@
           <a:p>
             <a:pPr algn="l">
               <a:lnSpc>
-                <a:spcPct val="108000"/>
+                <a:spcPct val="104000"/>
               </a:lnSpc>
               <a:spcAft>
-                <a:spcPts val="600"/>
+                <a:spcPts val="500"/>
               </a:spcAft>
             </a:pPr>
             <a:r>
-              <a:rPr sz="1200" b="1">
+              <a:rPr sz="1100" b="1">
                 <a:solidFill>
                   <a:srgbClr val="F2A93B"/>
                 </a:solidFill>
@@ -7056,7 +6999,7 @@
               <a:t>●  </a:t>
             </a:r>
             <a:r>
-              <a:rPr sz="1400">
+              <a:rPr sz="1300">
                 <a:solidFill>
                   <a:srgbClr val="1B2340"/>
                 </a:solidFill>
@@ -7068,14 +7011,14 @@
           <a:p>
             <a:pPr algn="l">
               <a:lnSpc>
-                <a:spcPct val="108000"/>
+                <a:spcPct val="104000"/>
               </a:lnSpc>
               <a:spcAft>
-                <a:spcPts val="600"/>
+                <a:spcPts val="500"/>
               </a:spcAft>
             </a:pPr>
             <a:r>
-              <a:rPr sz="1200" b="1">
+              <a:rPr sz="1100" b="1">
                 <a:solidFill>
                   <a:srgbClr val="F2A93B"/>
                 </a:solidFill>
@@ -7084,7 +7027,7 @@
               <a:t>●  </a:t>
             </a:r>
             <a:r>
-              <a:rPr sz="1400">
+              <a:rPr sz="1300">
                 <a:solidFill>
                   <a:srgbClr val="1B2340"/>
                 </a:solidFill>
@@ -7096,14 +7039,14 @@
           <a:p>
             <a:pPr algn="l">
               <a:lnSpc>
-                <a:spcPct val="108000"/>
+                <a:spcPct val="104000"/>
               </a:lnSpc>
               <a:spcAft>
-                <a:spcPts val="600"/>
+                <a:spcPts val="500"/>
               </a:spcAft>
             </a:pPr>
             <a:r>
-              <a:rPr sz="1200" b="1">
+              <a:rPr sz="1100" b="1">
                 <a:solidFill>
                   <a:srgbClr val="F2A93B"/>
                 </a:solidFill>
@@ -7112,84 +7055,73 @@
               <a:t>●  </a:t>
             </a:r>
             <a:r>
-              <a:rPr sz="1400">
+              <a:rPr sz="1300">
                 <a:solidFill>
                   <a:srgbClr val="1B2340"/>
                 </a:solidFill>
                 <a:latin typeface="Calibri"/>
               </a:rPr>
-              <a:t>Full audit trail of questions, answers, actions and the decision</a:t>
-            </a:r>
-          </a:p>
-        </p:txBody>
-      </p:sp>
-      <p:sp>
-        <p:nvSpPr>
-          <p:cNvPr id="24" name="TextBox 23"/>
-          <p:cNvSpPr txBox="1"/>
-          <p:nvPr/>
-        </p:nvSpPr>
-        <p:spPr>
-          <a:xfrm>
-            <a:off x="457200" y="6263640"/>
-            <a:ext cx="11277295" cy="365760"/>
-          </a:xfrm>
-          <a:prstGeom prst="rect">
-            <a:avLst/>
-          </a:prstGeom>
-          <a:noFill/>
-        </p:spPr>
-        <p:txBody>
-          <a:bodyPr wrap="square" anchor="t" lIns="0" rIns="0" tIns="0" bIns="0">
-            <a:spAutoFit/>
-          </a:bodyPr>
-          <a:lstStyle/>
-          <a:p>
-            <a:pPr algn="ctr">
-              <a:lnSpc>
-                <a:spcPct val="100000"/>
-              </a:lnSpc>
-            </a:pPr>
-            <a:r>
-              <a:rPr sz="1050" b="0" i="1">
-                <a:solidFill>
-                  <a:srgbClr val="555F75"/>
-                </a:solidFill>
-                <a:latin typeface="Calibri"/>
-              </a:rPr>
-              <a:t>Stack: Python · Streamlit · Google Gemini (structured output) · simulated giver and taker personas, one run, synthetic project · no GPU needed</a:t>
-            </a:r>
-          </a:p>
-        </p:txBody>
-      </p:sp>
-    </p:spTree>
-  </p:cSld>
-  <p:clrMapOvr>
-    <a:masterClrMapping/>
-  </p:clrMapOvr>
-</p:sld>
-</file>
-
-<file path=ppt/slides/slide3.xml><?xml version="1.0" encoding="utf-8"?>
-<p:sld xmlns:a="http://schemas.openxmlformats.org/drawingml/2006/main" xmlns:p="http://schemas.openxmlformats.org/presentationml/2006/main" xmlns:r="http://schemas.openxmlformats.org/officeDocument/2006/relationships">
-  <p:cSld>
-    <p:spTree>
-      <p:nvGrpSpPr>
-        <p:cNvPr id="1" name=""/>
-        <p:cNvGrpSpPr/>
-        <p:nvPr/>
-      </p:nvGrpSpPr>
-      <p:grpSpPr/>
-      <p:sp>
-        <p:nvSpPr>
-          <p:cNvPr id="2" name="Rectangle 1"/>
+              <a:t>Turns a KT into an auditable, escalation-ready workflow</a:t>
+            </a:r>
+          </a:p>
+        </p:txBody>
+      </p:sp>
+      <p:sp>
+        <p:nvSpPr>
+          <p:cNvPr id="24" name="Rounded Rectangle 23"/>
           <p:cNvSpPr/>
           <p:nvPr/>
         </p:nvSpPr>
         <p:spPr>
           <a:xfrm>
-            <a:off x="0" y="0"/>
-            <a:ext cx="12191695" cy="914400"/>
+            <a:off x="457200" y="4828032"/>
+            <a:ext cx="1780489" cy="914400"/>
+          </a:xfrm>
+          <a:prstGeom prst="roundRect">
+            <a:avLst>
+              <a:gd name="adj" fmla="val 6000"/>
+            </a:avLst>
+          </a:prstGeom>
+          <a:solidFill>
+            <a:srgbClr val="EDF1F8"/>
+          </a:solidFill>
+          <a:ln>
+            <a:noFill/>
+          </a:ln>
+          <a:effectLst/>
+        </p:spPr>
+        <p:style>
+          <a:lnRef idx="1">
+            <a:schemeClr val="accent1"/>
+          </a:lnRef>
+          <a:fillRef idx="3">
+            <a:schemeClr val="accent1"/>
+          </a:fillRef>
+          <a:effectRef idx="2">
+            <a:schemeClr val="accent1"/>
+          </a:effectRef>
+          <a:fontRef idx="minor">
+            <a:schemeClr val="lt1"/>
+          </a:fontRef>
+        </p:style>
+        <p:txBody>
+          <a:bodyPr rtlCol="0" anchor="ctr"/>
+          <a:lstStyle/>
+          <a:p>
+            <a:pPr algn="ctr"/>
+          </a:p>
+        </p:txBody>
+      </p:sp>
+      <p:sp>
+        <p:nvSpPr>
+          <p:cNvPr id="25" name="Rectangle 24"/>
+          <p:cNvSpPr/>
+          <p:nvPr/>
+        </p:nvSpPr>
+        <p:spPr>
+          <a:xfrm>
+            <a:off x="457200" y="4828032"/>
+            <a:ext cx="1780489" cy="292608"/>
           </a:xfrm>
           <a:prstGeom prst="rect">
             <a:avLst/>
@@ -7226,14 +7158,14 @@
       </p:sp>
       <p:sp>
         <p:nvSpPr>
-          <p:cNvPr id="3" name="TextBox 2"/>
+          <p:cNvPr id="26" name="TextBox 25"/>
           <p:cNvSpPr txBox="1"/>
           <p:nvPr/>
         </p:nvSpPr>
         <p:spPr>
           <a:xfrm>
-            <a:off x="457200" y="109728"/>
-            <a:ext cx="11247120" cy="457200"/>
+            <a:off x="548640" y="4846320"/>
+            <a:ext cx="1634185" cy="256032"/>
           </a:xfrm>
           <a:prstGeom prst="rect">
             <a:avLst/>
@@ -7241,7 +7173,7 @@
           <a:noFill/>
         </p:spPr>
         <p:txBody>
-          <a:bodyPr wrap="square" anchor="t" lIns="0" rIns="0" tIns="0" bIns="0">
+          <a:bodyPr wrap="square" anchor="ctr" lIns="0" rIns="0" tIns="0" bIns="0">
             <a:spAutoFit/>
           </a:bodyPr>
           <a:lstStyle/>
@@ -7252,27 +7184,27 @@
               </a:lnSpc>
             </a:pPr>
             <a:r>
-              <a:rPr sz="2600" b="1" i="0">
+              <a:rPr sz="1150" b="1" i="0">
                 <a:solidFill>
                   <a:srgbClr val="FFFFFF"/>
                 </a:solidFill>
-                <a:latin typeface="Cambria"/>
-              </a:rPr>
-              <a:t>Baton workflow: from project brief to a closed, evidenced KT</a:t>
-            </a:r>
-          </a:p>
-        </p:txBody>
-      </p:sp>
-      <p:sp>
-        <p:nvSpPr>
-          <p:cNvPr id="4" name="TextBox 3"/>
+                <a:latin typeface="Calibri"/>
+              </a:rPr>
+              <a:t>1 Brief</a:t>
+            </a:r>
+          </a:p>
+        </p:txBody>
+      </p:sp>
+      <p:sp>
+        <p:nvSpPr>
+          <p:cNvPr id="27" name="TextBox 26"/>
           <p:cNvSpPr txBox="1"/>
           <p:nvPr/>
         </p:nvSpPr>
         <p:spPr>
           <a:xfrm>
-            <a:off x="457200" y="576072"/>
-            <a:ext cx="11247120" cy="274320"/>
+            <a:off x="548640" y="5175504"/>
+            <a:ext cx="1597609" cy="530352"/>
           </a:xfrm>
           <a:prstGeom prst="rect">
             <a:avLst/>
@@ -7287,35 +7219,35 @@
           <a:p>
             <a:pPr algn="l">
               <a:lnSpc>
-                <a:spcPct val="100000"/>
+                <a:spcPct val="105000"/>
               </a:lnSpc>
             </a:pPr>
             <a:r>
-              <a:rPr sz="1300" b="0" i="1">
-                <a:solidFill>
-                  <a:srgbClr val="CADCFC"/>
-                </a:solidFill>
-                <a:latin typeface="Calibri"/>
-              </a:rPr>
-              <a:t>Independent giver and taker Q&amp;A, gap assessment, action items, review, and a decision the manager can track</a:t>
-            </a:r>
-          </a:p>
-        </p:txBody>
-      </p:sp>
-      <p:sp>
-        <p:nvSpPr>
-          <p:cNvPr id="5" name="Rounded Rectangle 4"/>
+              <a:rPr sz="900" b="0" i="0">
+                <a:solidFill>
+                  <a:srgbClr val="1B2340"/>
+                </a:solidFill>
+                <a:latin typeface="Calibri"/>
+              </a:rPr>
+              <a:t>PM enters project, roles, stack, dev/test env, duration</a:t>
+            </a:r>
+          </a:p>
+        </p:txBody>
+      </p:sp>
+      <p:sp>
+        <p:nvSpPr>
+          <p:cNvPr id="28" name="Rounded Rectangle 27"/>
           <p:cNvSpPr/>
           <p:nvPr/>
         </p:nvSpPr>
         <p:spPr>
           <a:xfrm>
-            <a:off x="457200" y="1115568"/>
-            <a:ext cx="1772869" cy="1874519"/>
+            <a:off x="2356561" y="4828032"/>
+            <a:ext cx="1780489" cy="914400"/>
           </a:xfrm>
           <a:prstGeom prst="roundRect">
             <a:avLst>
-              <a:gd name="adj" fmla="val 5000"/>
+              <a:gd name="adj" fmla="val 6000"/>
             </a:avLst>
           </a:prstGeom>
           <a:solidFill>
@@ -7350,14 +7282,14 @@
       </p:sp>
       <p:sp>
         <p:nvSpPr>
-          <p:cNvPr id="6" name="Rectangle 5"/>
+          <p:cNvPr id="29" name="Rectangle 28"/>
           <p:cNvSpPr/>
           <p:nvPr/>
         </p:nvSpPr>
         <p:spPr>
           <a:xfrm>
-            <a:off x="457200" y="1115568"/>
-            <a:ext cx="1772869" cy="384048"/>
+            <a:off x="2356561" y="4828032"/>
+            <a:ext cx="1780489" cy="292608"/>
           </a:xfrm>
           <a:prstGeom prst="rect">
             <a:avLst/>
@@ -7394,14 +7326,14 @@
       </p:sp>
       <p:sp>
         <p:nvSpPr>
-          <p:cNvPr id="7" name="TextBox 6"/>
+          <p:cNvPr id="30" name="TextBox 29"/>
           <p:cNvSpPr txBox="1"/>
           <p:nvPr/>
         </p:nvSpPr>
         <p:spPr>
           <a:xfrm>
-            <a:off x="566928" y="1152144"/>
-            <a:ext cx="1589989" cy="310896"/>
+            <a:off x="2448001" y="4846320"/>
+            <a:ext cx="1634185" cy="256032"/>
           </a:xfrm>
           <a:prstGeom prst="rect">
             <a:avLst/>
@@ -7420,27 +7352,27 @@
               </a:lnSpc>
             </a:pPr>
             <a:r>
-              <a:rPr sz="1300" b="1" i="0">
+              <a:rPr sz="1150" b="1" i="0">
                 <a:solidFill>
                   <a:srgbClr val="FFFFFF"/>
                 </a:solidFill>
                 <a:latin typeface="Calibri"/>
               </a:rPr>
-              <a:t>1 Brief</a:t>
-            </a:r>
-          </a:p>
-        </p:txBody>
-      </p:sp>
-      <p:sp>
-        <p:nvSpPr>
-          <p:cNvPr id="8" name="TextBox 7"/>
+              <a:t>2 Q&amp;A</a:t>
+            </a:r>
+          </a:p>
+        </p:txBody>
+      </p:sp>
+      <p:sp>
+        <p:nvSpPr>
+          <p:cNvPr id="31" name="TextBox 30"/>
           <p:cNvSpPr txBox="1"/>
           <p:nvPr/>
         </p:nvSpPr>
         <p:spPr>
           <a:xfrm>
-            <a:off x="566928" y="1618488"/>
-            <a:ext cx="1553413" cy="1325879"/>
+            <a:off x="2448001" y="5175504"/>
+            <a:ext cx="1597609" cy="530352"/>
           </a:xfrm>
           <a:prstGeom prst="rect">
             <a:avLst/>
@@ -7455,35 +7387,35 @@
           <a:p>
             <a:pPr algn="l">
               <a:lnSpc>
-                <a:spcPct val="100000"/>
+                <a:spcPct val="105000"/>
               </a:lnSpc>
             </a:pPr>
             <a:r>
-              <a:rPr sz="1050" b="0" i="0">
+              <a:rPr sz="900" b="0" i="0">
                 <a:solidFill>
                   <a:srgbClr val="1B2340"/>
                 </a:solidFill>
                 <a:latin typeface="Calibri"/>
               </a:rPr>
-              <a:t>PM enters project, roles, tech stack, dev/test env, duration, extra prompts</a:t>
-            </a:r>
-          </a:p>
-        </p:txBody>
-      </p:sp>
-      <p:sp>
-        <p:nvSpPr>
-          <p:cNvPr id="9" name="Rounded Rectangle 8"/>
+              <a:t>Giver &amp; taker answer independently across 12 KT angles</a:t>
+            </a:r>
+          </a:p>
+        </p:txBody>
+      </p:sp>
+      <p:sp>
+        <p:nvSpPr>
+          <p:cNvPr id="32" name="Rounded Rectangle 31"/>
           <p:cNvSpPr/>
           <p:nvPr/>
         </p:nvSpPr>
         <p:spPr>
           <a:xfrm>
-            <a:off x="2358085" y="1115568"/>
-            <a:ext cx="1772869" cy="1874519"/>
+            <a:off x="4255922" y="4828032"/>
+            <a:ext cx="1780489" cy="914400"/>
           </a:xfrm>
           <a:prstGeom prst="roundRect">
             <a:avLst>
-              <a:gd name="adj" fmla="val 5000"/>
+              <a:gd name="adj" fmla="val 6000"/>
             </a:avLst>
           </a:prstGeom>
           <a:solidFill>
@@ -7518,14 +7450,14 @@
       </p:sp>
       <p:sp>
         <p:nvSpPr>
-          <p:cNvPr id="10" name="Rectangle 9"/>
+          <p:cNvPr id="33" name="Rectangle 32"/>
           <p:cNvSpPr/>
           <p:nvPr/>
         </p:nvSpPr>
         <p:spPr>
           <a:xfrm>
-            <a:off x="2358085" y="1115568"/>
-            <a:ext cx="1772869" cy="384048"/>
+            <a:off x="4255922" y="4828032"/>
+            <a:ext cx="1780489" cy="292608"/>
           </a:xfrm>
           <a:prstGeom prst="rect">
             <a:avLst/>
@@ -7562,14 +7494,14 @@
       </p:sp>
       <p:sp>
         <p:nvSpPr>
-          <p:cNvPr id="11" name="TextBox 10"/>
+          <p:cNvPr id="34" name="TextBox 33"/>
           <p:cNvSpPr txBox="1"/>
           <p:nvPr/>
         </p:nvSpPr>
         <p:spPr>
           <a:xfrm>
-            <a:off x="2467813" y="1152144"/>
-            <a:ext cx="1589989" cy="310896"/>
+            <a:off x="4347362" y="4846320"/>
+            <a:ext cx="1634185" cy="256032"/>
           </a:xfrm>
           <a:prstGeom prst="rect">
             <a:avLst/>
@@ -7588,27 +7520,27 @@
               </a:lnSpc>
             </a:pPr>
             <a:r>
-              <a:rPr sz="1300" b="1" i="0">
+              <a:rPr sz="1150" b="1" i="0">
                 <a:solidFill>
                   <a:srgbClr val="FFFFFF"/>
                 </a:solidFill>
                 <a:latin typeface="Calibri"/>
               </a:rPr>
-              <a:t>2 Q&amp;A</a:t>
-            </a:r>
-          </a:p>
-        </p:txBody>
-      </p:sp>
-      <p:sp>
-        <p:nvSpPr>
-          <p:cNvPr id="12" name="TextBox 11"/>
+              <a:t>3 Assess</a:t>
+            </a:r>
+          </a:p>
+        </p:txBody>
+      </p:sp>
+      <p:sp>
+        <p:nvSpPr>
+          <p:cNvPr id="35" name="TextBox 34"/>
           <p:cNvSpPr txBox="1"/>
           <p:nvPr/>
         </p:nvSpPr>
         <p:spPr>
           <a:xfrm>
-            <a:off x="2467813" y="1618488"/>
-            <a:ext cx="1553413" cy="1325879"/>
+            <a:off x="4347362" y="5175504"/>
+            <a:ext cx="1597609" cy="530352"/>
           </a:xfrm>
           <a:prstGeom prst="rect">
             <a:avLst/>
@@ -7623,35 +7555,35 @@
           <a:p>
             <a:pPr algn="l">
               <a:lnSpc>
-                <a:spcPct val="100000"/>
+                <a:spcPct val="105000"/>
               </a:lnSpc>
             </a:pPr>
             <a:r>
-              <a:rPr sz="1050" b="0" i="0">
+              <a:rPr sz="900" b="0" i="0">
                 <a:solidFill>
                   <a:srgbClr val="1B2340"/>
                 </a:solidFill>
                 <a:latin typeface="Calibri"/>
               </a:rPr>
-              <a:t>Giver and taker answer separately. Round 1: 12 angles. Round 2: follow-ups on weak angles</a:t>
-            </a:r>
-          </a:p>
-        </p:txBody>
-      </p:sp>
-      <p:sp>
-        <p:nvSpPr>
-          <p:cNvPr id="13" name="Rounded Rectangle 12"/>
+              <a:t>AI compares both sides; quotes verified in code</a:t>
+            </a:r>
+          </a:p>
+        </p:txBody>
+      </p:sp>
+      <p:sp>
+        <p:nvSpPr>
+          <p:cNvPr id="36" name="Rounded Rectangle 35"/>
           <p:cNvSpPr/>
           <p:nvPr/>
         </p:nvSpPr>
         <p:spPr>
           <a:xfrm>
-            <a:off x="4258970" y="1115568"/>
-            <a:ext cx="1772869" cy="1874519"/>
+            <a:off x="6155283" y="4828032"/>
+            <a:ext cx="1780489" cy="914400"/>
           </a:xfrm>
           <a:prstGeom prst="roundRect">
             <a:avLst>
-              <a:gd name="adj" fmla="val 5000"/>
+              <a:gd name="adj" fmla="val 6000"/>
             </a:avLst>
           </a:prstGeom>
           <a:solidFill>
@@ -7686,14 +7618,14 @@
       </p:sp>
       <p:sp>
         <p:nvSpPr>
-          <p:cNvPr id="14" name="Rectangle 13"/>
+          <p:cNvPr id="37" name="Rectangle 36"/>
           <p:cNvSpPr/>
           <p:nvPr/>
         </p:nvSpPr>
         <p:spPr>
           <a:xfrm>
-            <a:off x="4258970" y="1115568"/>
-            <a:ext cx="1772869" cy="384048"/>
+            <a:off x="6155283" y="4828032"/>
+            <a:ext cx="1780489" cy="292608"/>
           </a:xfrm>
           <a:prstGeom prst="rect">
             <a:avLst/>
@@ -7730,14 +7662,14 @@
       </p:sp>
       <p:sp>
         <p:nvSpPr>
-          <p:cNvPr id="15" name="TextBox 14"/>
+          <p:cNvPr id="38" name="TextBox 37"/>
           <p:cNvSpPr txBox="1"/>
           <p:nvPr/>
         </p:nvSpPr>
         <p:spPr>
           <a:xfrm>
-            <a:off x="4368698" y="1152144"/>
-            <a:ext cx="1589989" cy="310896"/>
+            <a:off x="6246723" y="4846320"/>
+            <a:ext cx="1634185" cy="256032"/>
           </a:xfrm>
           <a:prstGeom prst="rect">
             <a:avLst/>
@@ -7756,27 +7688,27 @@
               </a:lnSpc>
             </a:pPr>
             <a:r>
-              <a:rPr sz="1300" b="1" i="0">
+              <a:rPr sz="1150" b="1" i="0">
                 <a:solidFill>
                   <a:srgbClr val="FFFFFF"/>
                 </a:solidFill>
                 <a:latin typeface="Calibri"/>
               </a:rPr>
-              <a:t>3 Assess</a:t>
-            </a:r>
-          </a:p>
-        </p:txBody>
-      </p:sp>
-      <p:sp>
-        <p:nvSpPr>
-          <p:cNvPr id="16" name="TextBox 15"/>
+              <a:t>4 Actions</a:t>
+            </a:r>
+          </a:p>
+        </p:txBody>
+      </p:sp>
+      <p:sp>
+        <p:nvSpPr>
+          <p:cNvPr id="39" name="TextBox 38"/>
           <p:cNvSpPr txBox="1"/>
           <p:nvPr/>
         </p:nvSpPr>
         <p:spPr>
           <a:xfrm>
-            <a:off x="4368698" y="1618488"/>
-            <a:ext cx="1553413" cy="1325879"/>
+            <a:off x="6246723" y="5175504"/>
+            <a:ext cx="1597609" cy="530352"/>
           </a:xfrm>
           <a:prstGeom prst="rect">
             <a:avLst/>
@@ -7791,35 +7723,35 @@
           <a:p>
             <a:pPr algn="l">
               <a:lnSpc>
-                <a:spcPct val="100000"/>
+                <a:spcPct val="105000"/>
               </a:lnSpc>
             </a:pPr>
             <a:r>
-              <a:rPr sz="1050" b="0" i="0">
+              <a:rPr sz="900" b="0" i="0">
                 <a:solidFill>
                   <a:srgbClr val="1B2340"/>
                 </a:solidFill>
                 <a:latin typeface="Calibri"/>
               </a:rPr>
-              <a:t>AI compares both sides per angle; quotes verified in code; readiness scored</a:t>
-            </a:r>
-          </a:p>
-        </p:txBody>
-      </p:sp>
-      <p:sp>
-        <p:nvSpPr>
-          <p:cNvPr id="17" name="Rounded Rectangle 16"/>
+              <a:t>Gaps become owned action items, with proof or justification</a:t>
+            </a:r>
+          </a:p>
+        </p:txBody>
+      </p:sp>
+      <p:sp>
+        <p:nvSpPr>
+          <p:cNvPr id="40" name="Rounded Rectangle 39"/>
           <p:cNvSpPr/>
           <p:nvPr/>
         </p:nvSpPr>
         <p:spPr>
           <a:xfrm>
-            <a:off x="6159855" y="1115568"/>
-            <a:ext cx="1772869" cy="1874519"/>
+            <a:off x="8054644" y="4828032"/>
+            <a:ext cx="1780489" cy="914400"/>
           </a:xfrm>
           <a:prstGeom prst="roundRect">
             <a:avLst>
-              <a:gd name="adj" fmla="val 5000"/>
+              <a:gd name="adj" fmla="val 6000"/>
             </a:avLst>
           </a:prstGeom>
           <a:solidFill>
@@ -7854,14 +7786,14 @@
       </p:sp>
       <p:sp>
         <p:nvSpPr>
-          <p:cNvPr id="18" name="Rectangle 17"/>
+          <p:cNvPr id="41" name="Rectangle 40"/>
           <p:cNvSpPr/>
           <p:nvPr/>
         </p:nvSpPr>
         <p:spPr>
           <a:xfrm>
-            <a:off x="6159855" y="1115568"/>
-            <a:ext cx="1772869" cy="384048"/>
+            <a:off x="8054644" y="4828032"/>
+            <a:ext cx="1780489" cy="292608"/>
           </a:xfrm>
           <a:prstGeom prst="rect">
             <a:avLst/>
@@ -7898,14 +7830,14 @@
       </p:sp>
       <p:sp>
         <p:nvSpPr>
-          <p:cNvPr id="19" name="TextBox 18"/>
+          <p:cNvPr id="42" name="TextBox 41"/>
           <p:cNvSpPr txBox="1"/>
           <p:nvPr/>
         </p:nvSpPr>
         <p:spPr>
           <a:xfrm>
-            <a:off x="6269583" y="1152144"/>
-            <a:ext cx="1589989" cy="310896"/>
+            <a:off x="8146084" y="4846320"/>
+            <a:ext cx="1634185" cy="256032"/>
           </a:xfrm>
           <a:prstGeom prst="rect">
             <a:avLst/>
@@ -7924,27 +7856,27 @@
               </a:lnSpc>
             </a:pPr>
             <a:r>
-              <a:rPr sz="1300" b="1" i="0">
+              <a:rPr sz="1150" b="1" i="0">
                 <a:solidFill>
                   <a:srgbClr val="FFFFFF"/>
                 </a:solidFill>
                 <a:latin typeface="Calibri"/>
               </a:rPr>
-              <a:t>4 Actions</a:t>
-            </a:r>
-          </a:p>
-        </p:txBody>
-      </p:sp>
-      <p:sp>
-        <p:nvSpPr>
-          <p:cNvPr id="20" name="TextBox 19"/>
+              <a:t>5 Review</a:t>
+            </a:r>
+          </a:p>
+        </p:txBody>
+      </p:sp>
+      <p:sp>
+        <p:nvSpPr>
+          <p:cNvPr id="43" name="TextBox 42"/>
           <p:cNvSpPr txBox="1"/>
           <p:nvPr/>
         </p:nvSpPr>
         <p:spPr>
           <a:xfrm>
-            <a:off x="6269583" y="1618488"/>
-            <a:ext cx="1553413" cy="1325879"/>
+            <a:off x="8146084" y="5175504"/>
+            <a:ext cx="1597609" cy="530352"/>
           </a:xfrm>
           <a:prstGeom prst="rect">
             <a:avLst/>
@@ -7959,35 +7891,35 @@
           <a:p>
             <a:pPr algn="l">
               <a:lnSpc>
-                <a:spcPct val="100000"/>
+                <a:spcPct val="105000"/>
               </a:lnSpc>
             </a:pPr>
             <a:r>
-              <a:rPr sz="1050" b="0" i="0">
+              <a:rPr sz="900" b="0" i="0">
                 <a:solidFill>
                   <a:srgbClr val="1B2340"/>
                 </a:solidFill>
                 <a:latin typeface="Calibri"/>
               </a:rPr>
-              <a:t>Gaps become action items for giver or taker; each replies with proof or a justification to ignore</a:t>
-            </a:r>
-          </a:p>
-        </p:txBody>
-      </p:sp>
-      <p:sp>
-        <p:nvSpPr>
-          <p:cNvPr id="21" name="Rounded Rectangle 20"/>
+              <a:t>AI reviews responses; weak justifications rejected</a:t>
+            </a:r>
+          </a:p>
+        </p:txBody>
+      </p:sp>
+      <p:sp>
+        <p:nvSpPr>
+          <p:cNvPr id="44" name="Rounded Rectangle 43"/>
           <p:cNvSpPr/>
           <p:nvPr/>
         </p:nvSpPr>
         <p:spPr>
           <a:xfrm>
-            <a:off x="8060740" y="1115568"/>
-            <a:ext cx="1772869" cy="1874519"/>
+            <a:off x="9954006" y="4828032"/>
+            <a:ext cx="1780489" cy="914400"/>
           </a:xfrm>
           <a:prstGeom prst="roundRect">
             <a:avLst>
-              <a:gd name="adj" fmla="val 5000"/>
+              <a:gd name="adj" fmla="val 6000"/>
             </a:avLst>
           </a:prstGeom>
           <a:solidFill>
@@ -8022,182 +7954,14 @@
       </p:sp>
       <p:sp>
         <p:nvSpPr>
-          <p:cNvPr id="22" name="Rectangle 21"/>
+          <p:cNvPr id="45" name="Rectangle 44"/>
           <p:cNvSpPr/>
           <p:nvPr/>
         </p:nvSpPr>
         <p:spPr>
           <a:xfrm>
-            <a:off x="8060740" y="1115568"/>
-            <a:ext cx="1772869" cy="384048"/>
-          </a:xfrm>
-          <a:prstGeom prst="rect">
-            <a:avLst/>
-          </a:prstGeom>
-          <a:solidFill>
-            <a:srgbClr val="1B2340"/>
-          </a:solidFill>
-          <a:ln>
-            <a:noFill/>
-          </a:ln>
-          <a:effectLst/>
-        </p:spPr>
-        <p:style>
-          <a:lnRef idx="1">
-            <a:schemeClr val="accent1"/>
-          </a:lnRef>
-          <a:fillRef idx="3">
-            <a:schemeClr val="accent1"/>
-          </a:fillRef>
-          <a:effectRef idx="2">
-            <a:schemeClr val="accent1"/>
-          </a:effectRef>
-          <a:fontRef idx="minor">
-            <a:schemeClr val="lt1"/>
-          </a:fontRef>
-        </p:style>
-        <p:txBody>
-          <a:bodyPr rtlCol="0" anchor="ctr"/>
-          <a:lstStyle/>
-          <a:p>
-            <a:pPr algn="ctr"/>
-          </a:p>
-        </p:txBody>
-      </p:sp>
-      <p:sp>
-        <p:nvSpPr>
-          <p:cNvPr id="23" name="TextBox 22"/>
-          <p:cNvSpPr txBox="1"/>
-          <p:nvPr/>
-        </p:nvSpPr>
-        <p:spPr>
-          <a:xfrm>
-            <a:off x="8170468" y="1152144"/>
-            <a:ext cx="1589989" cy="310896"/>
-          </a:xfrm>
-          <a:prstGeom prst="rect">
-            <a:avLst/>
-          </a:prstGeom>
-          <a:noFill/>
-        </p:spPr>
-        <p:txBody>
-          <a:bodyPr wrap="square" anchor="ctr" lIns="0" rIns="0" tIns="0" bIns="0">
-            <a:spAutoFit/>
-          </a:bodyPr>
-          <a:lstStyle/>
-          <a:p>
-            <a:pPr algn="l">
-              <a:lnSpc>
-                <a:spcPct val="100000"/>
-              </a:lnSpc>
-            </a:pPr>
-            <a:r>
-              <a:rPr sz="1300" b="1" i="0">
-                <a:solidFill>
-                  <a:srgbClr val="FFFFFF"/>
-                </a:solidFill>
-                <a:latin typeface="Calibri"/>
-              </a:rPr>
-              <a:t>5 Review</a:t>
-            </a:r>
-          </a:p>
-        </p:txBody>
-      </p:sp>
-      <p:sp>
-        <p:nvSpPr>
-          <p:cNvPr id="24" name="TextBox 23"/>
-          <p:cNvSpPr txBox="1"/>
-          <p:nvPr/>
-        </p:nvSpPr>
-        <p:spPr>
-          <a:xfrm>
-            <a:off x="8170468" y="1618488"/>
-            <a:ext cx="1553413" cy="1325879"/>
-          </a:xfrm>
-          <a:prstGeom prst="rect">
-            <a:avLst/>
-          </a:prstGeom>
-          <a:noFill/>
-        </p:spPr>
-        <p:txBody>
-          <a:bodyPr wrap="square" anchor="t" lIns="0" rIns="0" tIns="0" bIns="0">
-            <a:spAutoFit/>
-          </a:bodyPr>
-          <a:lstStyle/>
-          <a:p>
-            <a:pPr algn="l">
-              <a:lnSpc>
-                <a:spcPct val="100000"/>
-              </a:lnSpc>
-            </a:pPr>
-            <a:r>
-              <a:rPr sz="1050" b="0" i="0">
-                <a:solidFill>
-                  <a:srgbClr val="1B2340"/>
-                </a:solidFill>
-                <a:latin typeface="Calibri"/>
-              </a:rPr>
-              <a:t>AI reviews responses; vague or weak justifications are rejected with a reason</a:t>
-            </a:r>
-          </a:p>
-        </p:txBody>
-      </p:sp>
-      <p:sp>
-        <p:nvSpPr>
-          <p:cNvPr id="25" name="Rounded Rectangle 24"/>
-          <p:cNvSpPr/>
-          <p:nvPr/>
-        </p:nvSpPr>
-        <p:spPr>
-          <a:xfrm>
-            <a:off x="9961626" y="1115568"/>
-            <a:ext cx="1772869" cy="1874519"/>
-          </a:xfrm>
-          <a:prstGeom prst="roundRect">
-            <a:avLst>
-              <a:gd name="adj" fmla="val 5000"/>
-            </a:avLst>
-          </a:prstGeom>
-          <a:solidFill>
-            <a:srgbClr val="EDF1F8"/>
-          </a:solidFill>
-          <a:ln>
-            <a:noFill/>
-          </a:ln>
-          <a:effectLst/>
-        </p:spPr>
-        <p:style>
-          <a:lnRef idx="1">
-            <a:schemeClr val="accent1"/>
-          </a:lnRef>
-          <a:fillRef idx="3">
-            <a:schemeClr val="accent1"/>
-          </a:fillRef>
-          <a:effectRef idx="2">
-            <a:schemeClr val="accent1"/>
-          </a:effectRef>
-          <a:fontRef idx="minor">
-            <a:schemeClr val="lt1"/>
-          </a:fontRef>
-        </p:style>
-        <p:txBody>
-          <a:bodyPr rtlCol="0" anchor="ctr"/>
-          <a:lstStyle/>
-          <a:p>
-            <a:pPr algn="ctr"/>
-          </a:p>
-        </p:txBody>
-      </p:sp>
-      <p:sp>
-        <p:nvSpPr>
-          <p:cNvPr id="26" name="Rectangle 25"/>
-          <p:cNvSpPr/>
-          <p:nvPr/>
-        </p:nvSpPr>
-        <p:spPr>
-          <a:xfrm>
-            <a:off x="9961626" y="1115568"/>
-            <a:ext cx="1772869" cy="384048"/>
+            <a:off x="9954006" y="4828032"/>
+            <a:ext cx="1780489" cy="292608"/>
           </a:xfrm>
           <a:prstGeom prst="rect">
             <a:avLst/>
@@ -8234,14 +7998,14 @@
       </p:sp>
       <p:sp>
         <p:nvSpPr>
-          <p:cNvPr id="27" name="TextBox 26"/>
+          <p:cNvPr id="46" name="TextBox 45"/>
           <p:cNvSpPr txBox="1"/>
           <p:nvPr/>
         </p:nvSpPr>
         <p:spPr>
           <a:xfrm>
-            <a:off x="10071354" y="1152144"/>
-            <a:ext cx="1589989" cy="310896"/>
+            <a:off x="10045446" y="4846320"/>
+            <a:ext cx="1634185" cy="256032"/>
           </a:xfrm>
           <a:prstGeom prst="rect">
             <a:avLst/>
@@ -8260,7 +8024,7 @@
               </a:lnSpc>
             </a:pPr>
             <a:r>
-              <a:rPr sz="1300" b="1" i="0">
+              <a:rPr sz="1150" b="1" i="0">
                 <a:solidFill>
                   <a:srgbClr val="1B2340"/>
                 </a:solidFill>
@@ -8273,14 +8037,14 @@
       </p:sp>
       <p:sp>
         <p:nvSpPr>
-          <p:cNvPr id="28" name="TextBox 27"/>
+          <p:cNvPr id="47" name="TextBox 46"/>
           <p:cNvSpPr txBox="1"/>
           <p:nvPr/>
         </p:nvSpPr>
         <p:spPr>
           <a:xfrm>
-            <a:off x="10071354" y="1618488"/>
-            <a:ext cx="1553413" cy="1325879"/>
+            <a:off x="10045446" y="5175504"/>
+            <a:ext cx="1597609" cy="530352"/>
           </a:xfrm>
           <a:prstGeom prst="rect">
             <a:avLst/>
@@ -8295,31 +8059,31 @@
           <a:p>
             <a:pPr algn="l">
               <a:lnSpc>
-                <a:spcPct val="100000"/>
+                <a:spcPct val="105000"/>
               </a:lnSpc>
             </a:pPr>
             <a:r>
-              <a:rPr sz="1050" b="0" i="0">
+              <a:rPr sz="900" b="0" i="0">
                 <a:solidFill>
                   <a:srgbClr val="1B2340"/>
                 </a:solidFill>
                 <a:latin typeface="Calibri"/>
               </a:rPr>
-              <a:t>Code rule: Close, keep open for one redress round, or Escalate to manager</a:t>
-            </a:r>
-          </a:p>
-        </p:txBody>
-      </p:sp>
-      <p:sp>
-        <p:nvSpPr>
-          <p:cNvPr id="29" name="TextBox 28"/>
+              <a:t>Code: Close, one redress round, or Escalate</a:t>
+            </a:r>
+          </a:p>
+        </p:txBody>
+      </p:sp>
+      <p:sp>
+        <p:nvSpPr>
+          <p:cNvPr id="48" name="TextBox 47"/>
           <p:cNvSpPr txBox="1"/>
           <p:nvPr/>
         </p:nvSpPr>
         <p:spPr>
           <a:xfrm>
-            <a:off x="457200" y="3044951"/>
-            <a:ext cx="11277295" cy="256032"/>
+            <a:off x="457200" y="5769864"/>
+            <a:ext cx="11277295" cy="201168"/>
           </a:xfrm>
           <a:prstGeom prst="rect">
             <a:avLst/>
@@ -8338,686 +8102,26 @@
               </a:lnSpc>
             </a:pPr>
             <a:r>
-              <a:rPr sz="1050" b="0" i="1">
+              <a:rPr sz="950" b="0" i="1">
                 <a:solidFill>
                   <a:srgbClr val="555F75"/>
                 </a:solidFill>
                 <a:latin typeface="Calibri"/>
               </a:rPr>
-              <a:t>Redress loop: unresolved items return to their owner once, with the reviewer's note. Still unresolved: escalated.</a:t>
-            </a:r>
-          </a:p>
-        </p:txBody>
-      </p:sp>
-      <p:sp>
-        <p:nvSpPr>
-          <p:cNvPr id="30" name="Rounded Rectangle 29"/>
-          <p:cNvSpPr/>
-          <p:nvPr/>
-        </p:nvSpPr>
-        <p:spPr>
-          <a:xfrm>
-            <a:off x="457200" y="3401568"/>
-            <a:ext cx="3637178" cy="2788920"/>
-          </a:xfrm>
-          <a:prstGeom prst="roundRect">
-            <a:avLst>
-              <a:gd name="adj" fmla="val 4000"/>
-            </a:avLst>
-          </a:prstGeom>
-          <a:solidFill>
-            <a:srgbClr val="EDF1F8"/>
-          </a:solidFill>
-          <a:ln>
-            <a:noFill/>
-          </a:ln>
-          <a:effectLst/>
-        </p:spPr>
-        <p:style>
-          <a:lnRef idx="1">
-            <a:schemeClr val="accent1"/>
-          </a:lnRef>
-          <a:fillRef idx="3">
-            <a:schemeClr val="accent1"/>
-          </a:fillRef>
-          <a:effectRef idx="2">
-            <a:schemeClr val="accent1"/>
-          </a:effectRef>
-          <a:fontRef idx="minor">
-            <a:schemeClr val="lt1"/>
-          </a:fontRef>
-        </p:style>
-        <p:txBody>
-          <a:bodyPr rtlCol="0" anchor="ctr"/>
-          <a:lstStyle/>
-          <a:p>
-            <a:pPr algn="ctr"/>
-          </a:p>
-        </p:txBody>
-      </p:sp>
-      <p:sp>
-        <p:nvSpPr>
-          <p:cNvPr id="31" name="TextBox 30"/>
+              <a:t>Redress loop: a rejected item returns to its owner once, with the reviewer's note. Still unresolved: escalated to the manager.</a:t>
+            </a:r>
+          </a:p>
+        </p:txBody>
+      </p:sp>
+      <p:sp>
+        <p:nvSpPr>
+          <p:cNvPr id="49" name="TextBox 48"/>
           <p:cNvSpPr txBox="1"/>
           <p:nvPr/>
         </p:nvSpPr>
         <p:spPr>
           <a:xfrm>
-            <a:off x="640080" y="3511296"/>
-            <a:ext cx="3271418" cy="310896"/>
-          </a:xfrm>
-          <a:prstGeom prst="rect">
-            <a:avLst/>
-          </a:prstGeom>
-          <a:noFill/>
-        </p:spPr>
-        <p:txBody>
-          <a:bodyPr wrap="square" anchor="t" lIns="0" rIns="0" tIns="0" bIns="0">
-            <a:spAutoFit/>
-          </a:bodyPr>
-          <a:lstStyle/>
-          <a:p>
-            <a:pPr algn="l">
-              <a:lnSpc>
-                <a:spcPct val="100000"/>
-              </a:lnSpc>
-            </a:pPr>
-            <a:r>
-              <a:rPr sz="1400" b="1" i="0">
-                <a:solidFill>
-                  <a:srgbClr val="1B2340"/>
-                </a:solidFill>
-                <a:latin typeface="Calibri"/>
-              </a:rPr>
-              <a:t>Scoring and live eval</a:t>
-            </a:r>
-          </a:p>
-        </p:txBody>
-      </p:sp>
-      <p:sp>
-        <p:nvSpPr>
-          <p:cNvPr id="32" name="TextBox 31"/>
-          <p:cNvSpPr txBox="1"/>
-          <p:nvPr/>
-        </p:nvSpPr>
-        <p:spPr>
-          <a:xfrm>
-            <a:off x="640080" y="3904488"/>
-            <a:ext cx="3271418" cy="2194560"/>
-          </a:xfrm>
-          <a:prstGeom prst="rect">
-            <a:avLst/>
-          </a:prstGeom>
-          <a:noFill/>
-        </p:spPr>
-        <p:txBody>
-          <a:bodyPr wrap="square" lIns="0" rIns="0" tIns="0" bIns="0">
-            <a:spAutoFit/>
-          </a:bodyPr>
-          <a:lstStyle/>
-          <a:p>
-            <a:pPr algn="l">
-              <a:lnSpc>
-                <a:spcPct val="108000"/>
-              </a:lnSpc>
-              <a:spcAft>
-                <a:spcPts val="400"/>
-              </a:spcAft>
-            </a:pPr>
-            <a:r>
-              <a:rPr sz="850" b="1">
-                <a:solidFill>
-                  <a:srgbClr val="F2A93B"/>
-                </a:solidFill>
-                <a:latin typeface="Calibri"/>
-              </a:rPr>
-              <a:t>●  </a:t>
-            </a:r>
-            <a:r>
-              <a:rPr sz="1050">
-                <a:solidFill>
-                  <a:srgbClr val="1B2340"/>
-                </a:solidFill>
-                <a:latin typeface="Calibri"/>
-              </a:rPr>
-              <a:t>Readiness = weighted share of 12 angles: architecture, environments, CI/CD, incidents, security, in-flight work and more</a:t>
-            </a:r>
-          </a:p>
-          <a:p>
-            <a:pPr algn="l">
-              <a:lnSpc>
-                <a:spcPct val="108000"/>
-              </a:lnSpc>
-              <a:spcAft>
-                <a:spcPts val="400"/>
-              </a:spcAft>
-            </a:pPr>
-            <a:r>
-              <a:rPr sz="850" b="1">
-                <a:solidFill>
-                  <a:srgbClr val="F2A93B"/>
-                </a:solidFill>
-                <a:latin typeface="Calibri"/>
-              </a:rPr>
-              <a:t>●  </a:t>
-            </a:r>
-            <a:r>
-              <a:rPr sz="1050">
-                <a:solidFill>
-                  <a:srgbClr val="1B2340"/>
-                </a:solidFill>
-                <a:latin typeface="Calibri"/>
-              </a:rPr>
-              <a:t>Covered only if both sides give verifiable quotes and the taker's answer matches the giver's</a:t>
-            </a:r>
-          </a:p>
-          <a:p>
-            <a:pPr algn="l">
-              <a:lnSpc>
-                <a:spcPct val="108000"/>
-              </a:lnSpc>
-              <a:spcAft>
-                <a:spcPts val="400"/>
-              </a:spcAft>
-            </a:pPr>
-            <a:r>
-              <a:rPr sz="850" b="1">
-                <a:solidFill>
-                  <a:srgbClr val="F2A93B"/>
-                </a:solidFill>
-                <a:latin typeface="Calibri"/>
-              </a:rPr>
-              <a:t>●  </a:t>
-            </a:r>
-            <a:r>
-              <a:rPr sz="1050">
-                <a:solidFill>
-                  <a:srgbClr val="1B2340"/>
-                </a:solidFill>
-                <a:latin typeface="Calibri"/>
-              </a:rPr>
-              <a:t>Close needs every action accepted and readiness at or above the manager's target (default 80%)</a:t>
-            </a:r>
-          </a:p>
-          <a:p>
-            <a:pPr algn="l">
-              <a:lnSpc>
-                <a:spcPct val="108000"/>
-              </a:lnSpc>
-              <a:spcAft>
-                <a:spcPts val="400"/>
-              </a:spcAft>
-            </a:pPr>
-            <a:r>
-              <a:rPr sz="850" b="1">
-                <a:solidFill>
-                  <a:srgbClr val="F2A93B"/>
-                </a:solidFill>
-                <a:latin typeface="Calibri"/>
-              </a:rPr>
-              <a:t>●  </a:t>
-            </a:r>
-            <a:r>
-              <a:rPr sz="1050">
-                <a:solidFill>
-                  <a:srgbClr val="1B2340"/>
-                </a:solidFill>
-                <a:latin typeface="Calibri"/>
-              </a:rPr>
-              <a:t>Live readiness trail: 57% → 66% → 95% → 97%; closed after 1 redress round</a:t>
-            </a:r>
-          </a:p>
-        </p:txBody>
-      </p:sp>
-      <p:sp>
-        <p:nvSpPr>
-          <p:cNvPr id="33" name="Rounded Rectangle 32"/>
-          <p:cNvSpPr/>
-          <p:nvPr/>
-        </p:nvSpPr>
-        <p:spPr>
-          <a:xfrm>
-            <a:off x="4277258" y="3401568"/>
-            <a:ext cx="3637178" cy="2788920"/>
-          </a:xfrm>
-          <a:prstGeom prst="roundRect">
-            <a:avLst>
-              <a:gd name="adj" fmla="val 4000"/>
-            </a:avLst>
-          </a:prstGeom>
-          <a:solidFill>
-            <a:srgbClr val="EDF1F8"/>
-          </a:solidFill>
-          <a:ln>
-            <a:noFill/>
-          </a:ln>
-          <a:effectLst/>
-        </p:spPr>
-        <p:style>
-          <a:lnRef idx="1">
-            <a:schemeClr val="accent1"/>
-          </a:lnRef>
-          <a:fillRef idx="3">
-            <a:schemeClr val="accent1"/>
-          </a:fillRef>
-          <a:effectRef idx="2">
-            <a:schemeClr val="accent1"/>
-          </a:effectRef>
-          <a:fontRef idx="minor">
-            <a:schemeClr val="lt1"/>
-          </a:fontRef>
-        </p:style>
-        <p:txBody>
-          <a:bodyPr rtlCol="0" anchor="ctr"/>
-          <a:lstStyle/>
-          <a:p>
-            <a:pPr algn="ctr"/>
-          </a:p>
-        </p:txBody>
-      </p:sp>
-      <p:sp>
-        <p:nvSpPr>
-          <p:cNvPr id="34" name="TextBox 33"/>
-          <p:cNvSpPr txBox="1"/>
-          <p:nvPr/>
-        </p:nvSpPr>
-        <p:spPr>
-          <a:xfrm>
-            <a:off x="4460138" y="3511296"/>
-            <a:ext cx="3271418" cy="310896"/>
-          </a:xfrm>
-          <a:prstGeom prst="rect">
-            <a:avLst/>
-          </a:prstGeom>
-          <a:noFill/>
-        </p:spPr>
-        <p:txBody>
-          <a:bodyPr wrap="square" anchor="t" lIns="0" rIns="0" tIns="0" bIns="0">
-            <a:spAutoFit/>
-          </a:bodyPr>
-          <a:lstStyle/>
-          <a:p>
-            <a:pPr algn="l">
-              <a:lnSpc>
-                <a:spcPct val="100000"/>
-              </a:lnSpc>
-            </a:pPr>
-            <a:r>
-              <a:rPr sz="1400" b="1" i="0">
-                <a:solidFill>
-                  <a:srgbClr val="1B2340"/>
-                </a:solidFill>
-                <a:latin typeface="Calibri"/>
-              </a:rPr>
-              <a:t>Manager tracker</a:t>
-            </a:r>
-          </a:p>
-        </p:txBody>
-      </p:sp>
-      <p:sp>
-        <p:nvSpPr>
-          <p:cNvPr id="35" name="TextBox 34"/>
-          <p:cNvSpPr txBox="1"/>
-          <p:nvPr/>
-        </p:nvSpPr>
-        <p:spPr>
-          <a:xfrm>
-            <a:off x="4460138" y="3904488"/>
-            <a:ext cx="3271418" cy="2194560"/>
-          </a:xfrm>
-          <a:prstGeom prst="rect">
-            <a:avLst/>
-          </a:prstGeom>
-          <a:noFill/>
-        </p:spPr>
-        <p:txBody>
-          <a:bodyPr wrap="square" lIns="0" rIns="0" tIns="0" bIns="0">
-            <a:spAutoFit/>
-          </a:bodyPr>
-          <a:lstStyle/>
-          <a:p>
-            <a:pPr algn="l">
-              <a:lnSpc>
-                <a:spcPct val="108000"/>
-              </a:lnSpc>
-              <a:spcAft>
-                <a:spcPts val="400"/>
-              </a:spcAft>
-            </a:pPr>
-            <a:r>
-              <a:rPr sz="850" b="1">
-                <a:solidFill>
-                  <a:srgbClr val="F2A93B"/>
-                </a:solidFill>
-                <a:latin typeface="Calibri"/>
-              </a:rPr>
-              <a:t>●  </a:t>
-            </a:r>
-            <a:r>
-              <a:rPr sz="1050">
-                <a:solidFill>
-                  <a:srgbClr val="1B2340"/>
-                </a:solidFill>
-                <a:latin typeface="Calibri"/>
-              </a:rPr>
-              <a:t>Every KT: stage, day n of N, deadline, days left, overdue flag</a:t>
-            </a:r>
-          </a:p>
-          <a:p>
-            <a:pPr algn="l">
-              <a:lnSpc>
-                <a:spcPct val="108000"/>
-              </a:lnSpc>
-              <a:spcAft>
-                <a:spcPts val="400"/>
-              </a:spcAft>
-            </a:pPr>
-            <a:r>
-              <a:rPr sz="850" b="1">
-                <a:solidFill>
-                  <a:srgbClr val="F2A93B"/>
-                </a:solidFill>
-                <a:latin typeface="Calibri"/>
-              </a:rPr>
-              <a:t>●  </a:t>
-            </a:r>
-            <a:r>
-              <a:rPr sz="1050">
-                <a:solidFill>
-                  <a:srgbClr val="1B2340"/>
-                </a:solidFill>
-                <a:latin typeface="Calibri"/>
-              </a:rPr>
-              <a:t>Who each KT is waiting on: giver, taker or manager</a:t>
-            </a:r>
-          </a:p>
-          <a:p>
-            <a:pPr algn="l">
-              <a:lnSpc>
-                <a:spcPct val="108000"/>
-              </a:lnSpc>
-              <a:spcAft>
-                <a:spcPts val="400"/>
-              </a:spcAft>
-            </a:pPr>
-            <a:r>
-              <a:rPr sz="850" b="1">
-                <a:solidFill>
-                  <a:srgbClr val="F2A93B"/>
-                </a:solidFill>
-                <a:latin typeface="Calibri"/>
-              </a:rPr>
-              <a:t>●  </a:t>
-            </a:r>
-            <a:r>
-              <a:rPr sz="1050">
-                <a:solidFill>
-                  <a:srgbClr val="1B2340"/>
-                </a:solidFill>
-                <a:latin typeface="Calibri"/>
-              </a:rPr>
-              <a:t>Action items across KTs with owner, severity, due date, state</a:t>
-            </a:r>
-          </a:p>
-          <a:p>
-            <a:pPr algn="l">
-              <a:lnSpc>
-                <a:spcPct val="108000"/>
-              </a:lnSpc>
-              <a:spcAft>
-                <a:spcPts val="400"/>
-              </a:spcAft>
-            </a:pPr>
-            <a:r>
-              <a:rPr sz="850" b="1">
-                <a:solidFill>
-                  <a:srgbClr val="F2A93B"/>
-                </a:solidFill>
-                <a:latin typeface="Calibri"/>
-              </a:rPr>
-              <a:t>●  </a:t>
-            </a:r>
-            <a:r>
-              <a:rPr sz="1050">
-                <a:solidFill>
-                  <a:srgbClr val="1B2340"/>
-                </a:solidFill>
-                <a:latin typeface="Calibri"/>
-              </a:rPr>
-              <a:t>Timeline of stage changes, time in stage, readiness trend, override with a note</a:t>
-            </a:r>
-          </a:p>
-        </p:txBody>
-      </p:sp>
-      <p:sp>
-        <p:nvSpPr>
-          <p:cNvPr id="36" name="Rounded Rectangle 35"/>
-          <p:cNvSpPr/>
-          <p:nvPr/>
-        </p:nvSpPr>
-        <p:spPr>
-          <a:xfrm>
-            <a:off x="8097316" y="3401568"/>
-            <a:ext cx="3637178" cy="2788920"/>
-          </a:xfrm>
-          <a:prstGeom prst="roundRect">
-            <a:avLst>
-              <a:gd name="adj" fmla="val 4000"/>
-            </a:avLst>
-          </a:prstGeom>
-          <a:solidFill>
-            <a:srgbClr val="EDF1F8"/>
-          </a:solidFill>
-          <a:ln>
-            <a:noFill/>
-          </a:ln>
-          <a:effectLst/>
-        </p:spPr>
-        <p:style>
-          <a:lnRef idx="1">
-            <a:schemeClr val="accent1"/>
-          </a:lnRef>
-          <a:fillRef idx="3">
-            <a:schemeClr val="accent1"/>
-          </a:fillRef>
-          <a:effectRef idx="2">
-            <a:schemeClr val="accent1"/>
-          </a:effectRef>
-          <a:fontRef idx="minor">
-            <a:schemeClr val="lt1"/>
-          </a:fontRef>
-        </p:style>
-        <p:txBody>
-          <a:bodyPr rtlCol="0" anchor="ctr"/>
-          <a:lstStyle/>
-          <a:p>
-            <a:pPr algn="ctr"/>
-          </a:p>
-        </p:txBody>
-      </p:sp>
-      <p:sp>
-        <p:nvSpPr>
-          <p:cNvPr id="37" name="TextBox 36"/>
-          <p:cNvSpPr txBox="1"/>
-          <p:nvPr/>
-        </p:nvSpPr>
-        <p:spPr>
-          <a:xfrm>
-            <a:off x="8280196" y="3511296"/>
-            <a:ext cx="3271418" cy="310896"/>
-          </a:xfrm>
-          <a:prstGeom prst="rect">
-            <a:avLst/>
-          </a:prstGeom>
-          <a:noFill/>
-        </p:spPr>
-        <p:txBody>
-          <a:bodyPr wrap="square" anchor="t" lIns="0" rIns="0" tIns="0" bIns="0">
-            <a:spAutoFit/>
-          </a:bodyPr>
-          <a:lstStyle/>
-          <a:p>
-            <a:pPr algn="l">
-              <a:lnSpc>
-                <a:spcPct val="100000"/>
-              </a:lnSpc>
-            </a:pPr>
-            <a:r>
-              <a:rPr sz="1400" b="1" i="0">
-                <a:solidFill>
-                  <a:srgbClr val="1B2340"/>
-                </a:solidFill>
-                <a:latin typeface="Calibri"/>
-              </a:rPr>
-              <a:t>AI, code and human</a:t>
-            </a:r>
-          </a:p>
-        </p:txBody>
-      </p:sp>
-      <p:sp>
-        <p:nvSpPr>
-          <p:cNvPr id="38" name="TextBox 37"/>
-          <p:cNvSpPr txBox="1"/>
-          <p:nvPr/>
-        </p:nvSpPr>
-        <p:spPr>
-          <a:xfrm>
-            <a:off x="8280196" y="3904488"/>
-            <a:ext cx="3271418" cy="2194560"/>
-          </a:xfrm>
-          <a:prstGeom prst="rect">
-            <a:avLst/>
-          </a:prstGeom>
-          <a:noFill/>
-        </p:spPr>
-        <p:txBody>
-          <a:bodyPr wrap="square" lIns="0" rIns="0" tIns="0" bIns="0">
-            <a:spAutoFit/>
-          </a:bodyPr>
-          <a:lstStyle/>
-          <a:p>
-            <a:pPr algn="l">
-              <a:lnSpc>
-                <a:spcPct val="108000"/>
-              </a:lnSpc>
-              <a:spcAft>
-                <a:spcPts val="400"/>
-              </a:spcAft>
-            </a:pPr>
-            <a:r>
-              <a:rPr sz="850" b="1">
-                <a:solidFill>
-                  <a:srgbClr val="F2A93B"/>
-                </a:solidFill>
-                <a:latin typeface="Calibri"/>
-              </a:rPr>
-              <a:t>●  </a:t>
-            </a:r>
-            <a:r>
-              <a:rPr sz="1050">
-                <a:solidFill>
-                  <a:srgbClr val="1B2340"/>
-                </a:solidFill>
-                <a:latin typeface="Calibri"/>
-              </a:rPr>
-              <a:t>AI: writes the questions, compares answers, recommends actions, reviews responses</a:t>
-            </a:r>
-          </a:p>
-          <a:p>
-            <a:pPr algn="l">
-              <a:lnSpc>
-                <a:spcPct val="108000"/>
-              </a:lnSpc>
-              <a:spcAft>
-                <a:spcPts val="400"/>
-              </a:spcAft>
-            </a:pPr>
-            <a:r>
-              <a:rPr sz="850" b="1">
-                <a:solidFill>
-                  <a:srgbClr val="F2A93B"/>
-                </a:solidFill>
-                <a:latin typeface="Calibri"/>
-              </a:rPr>
-              <a:t>●  </a:t>
-            </a:r>
-            <a:r>
-              <a:rPr sz="1050">
-                <a:solidFill>
-                  <a:srgbClr val="1B2340"/>
-                </a:solidFill>
-                <a:latin typeface="Calibri"/>
-              </a:rPr>
-              <a:t>Code: verifies quotes, scores readiness, applies the close / redress / escalate rule, tracks dates</a:t>
-            </a:r>
-          </a:p>
-          <a:p>
-            <a:pPr algn="l">
-              <a:lnSpc>
-                <a:spcPct val="108000"/>
-              </a:lnSpc>
-              <a:spcAft>
-                <a:spcPts val="400"/>
-              </a:spcAft>
-            </a:pPr>
-            <a:r>
-              <a:rPr sz="850" b="1">
-                <a:solidFill>
-                  <a:srgbClr val="F2A93B"/>
-                </a:solidFill>
-                <a:latin typeface="Calibri"/>
-              </a:rPr>
-              <a:t>●  </a:t>
-            </a:r>
-            <a:r>
-              <a:rPr sz="1050">
-                <a:solidFill>
-                  <a:srgbClr val="1B2340"/>
-                </a:solidFill>
-                <a:latin typeface="Calibri"/>
-              </a:rPr>
-              <a:t>Giver and taker: answer independently; act on items or justify ignoring them</a:t>
-            </a:r>
-          </a:p>
-          <a:p>
-            <a:pPr algn="l">
-              <a:lnSpc>
-                <a:spcPct val="108000"/>
-              </a:lnSpc>
-              <a:spcAft>
-                <a:spcPts val="400"/>
-              </a:spcAft>
-            </a:pPr>
-            <a:r>
-              <a:rPr sz="850" b="1">
-                <a:solidFill>
-                  <a:srgbClr val="F2A93B"/>
-                </a:solidFill>
-                <a:latin typeface="Calibri"/>
-              </a:rPr>
-              <a:t>●  </a:t>
-            </a:r>
-            <a:r>
-              <a:rPr sz="1050">
-                <a:solidFill>
-                  <a:srgbClr val="1B2340"/>
-                </a:solidFill>
-                <a:latin typeface="Calibri"/>
-              </a:rPr>
-              <a:t>Manager: sets inputs and target; owns escalations and overrides</a:t>
-            </a:r>
-          </a:p>
-        </p:txBody>
-      </p:sp>
-      <p:sp>
-        <p:nvSpPr>
-          <p:cNvPr id="39" name="TextBox 38"/>
-          <p:cNvSpPr txBox="1"/>
-          <p:nvPr/>
-        </p:nvSpPr>
-        <p:spPr>
-          <a:xfrm>
-            <a:off x="457200" y="6355080"/>
+            <a:off x="457200" y="6016752"/>
             <a:ext cx="11277295" cy="274320"/>
           </a:xfrm>
           <a:prstGeom prst="rect">
@@ -9037,13 +8141,52 @@
               </a:lnSpc>
             </a:pPr>
             <a:r>
-              <a:rPr sz="950" b="0" i="1">
+              <a:rPr sz="1000" b="0" i="1">
                 <a:solidFill>
                   <a:srgbClr val="555F75"/>
                 </a:solidFill>
                 <a:latin typeface="Calibri"/>
               </a:rPr>
-              <a:t>Eval: simulated giver and taker personas with 4 planted weak angles, one synthetic project, one run (69 s end to end). The target is a stopping rule, not proof of completeness.</a:t>
+              <a:t>Stack: Python · Streamlit · Google Gemini (structured output), Groq fallback on outage/quota · no GPU needed</a:t>
+            </a:r>
+          </a:p>
+        </p:txBody>
+      </p:sp>
+      <p:sp>
+        <p:nvSpPr>
+          <p:cNvPr id="50" name="TextBox 49"/>
+          <p:cNvSpPr txBox="1"/>
+          <p:nvPr/>
+        </p:nvSpPr>
+        <p:spPr>
+          <a:xfrm>
+            <a:off x="457200" y="6281928"/>
+            <a:ext cx="11277295" cy="274320"/>
+          </a:xfrm>
+          <a:prstGeom prst="rect">
+            <a:avLst/>
+          </a:prstGeom>
+          <a:noFill/>
+        </p:spPr>
+        <p:txBody>
+          <a:bodyPr wrap="square" anchor="t" lIns="0" rIns="0" tIns="0" bIns="0">
+            <a:spAutoFit/>
+          </a:bodyPr>
+          <a:lstStyle/>
+          <a:p>
+            <a:pPr algn="ctr">
+              <a:lnSpc>
+                <a:spcPct val="100000"/>
+              </a:lnSpc>
+            </a:pPr>
+            <a:r>
+              <a:rPr sz="900" b="0" i="1">
+                <a:solidFill>
+                  <a:srgbClr val="555F75"/>
+                </a:solidFill>
+                <a:latin typeface="Calibri"/>
+              </a:rPr>
+              <a:t>Eval: simulated giver/taker personas, 4 planted weak angles, one synthetic project, one run (69s end to end). Target is a stopping rule, not proof of completeness.</a:t>
             </a:r>
           </a:p>
         </p:txBody>

</xml_diff>